<commit_message>
Fix Ch14 slide 7 YouTube URL overlapping last bullet
Bullet text box at y=1.5 extended past the URL at y=5.05, causing
the hyperlink text to render on top of "休止符表達驚愕...".
Tighten bullet font 20→19, lineSpacing 1.3→1.2, shrink box h 3.8→3.4,
and shift URL to y=5.15.

Co-Authored-By: Claude Opus 4.7 <noreply@anthropic.com>
</commit_message>
<xml_diff>
--- a/Ch14_Opera.pptx
+++ b/Ch14_Opera.pptx
@@ -11789,7 +11789,7 @@
         <p:spPr>
           <a:xfrm>
             <a:off x="457200" y="1371600"/>
-            <a:ext cx="8229600" cy="3474720"/>
+            <a:ext cx="8229600" cy="3108960"/>
           </a:xfrm>
           <a:prstGeom prst="rect">
             <a:avLst/>
@@ -11803,12 +11803,12 @@
           <a:p>
             <a:pPr indent="0" marL="0">
               <a:lnSpc>
-                <a:spcPct val="130000"/>
-              </a:lnSpc>
-              <a:buNone/>
-            </a:pPr>
-            <a:r>
-              <a:rPr lang="en-US" sz="2000" dirty="0">
+                <a:spcPct val="120000"/>
+              </a:lnSpc>
+              <a:buNone/>
+            </a:pPr>
+            <a:r>
+              <a:rPr lang="en-US" sz="1900" dirty="0">
                 <a:solidFill>
                   <a:srgbClr val="F5F0E0"/>
                 </a:solidFill>
@@ -11818,17 +11818,17 @@
               </a:rPr>
               <a:t>Tirsi 的詠嘆調 (strophic aria)</a:t>
             </a:r>
-            <a:endParaRPr lang="en-US" sz="2000" dirty="0"/>
-          </a:p>
-          <a:p>
-            <a:pPr indent="0" marL="0">
-              <a:lnSpc>
-                <a:spcPct val="130000"/>
-              </a:lnSpc>
-              <a:buNone/>
-            </a:pPr>
-            <a:r>
-              <a:rPr lang="en-US" sz="2000" dirty="0">
+            <a:endParaRPr lang="en-US" sz="1900" dirty="0"/>
+          </a:p>
+          <a:p>
+            <a:pPr indent="0" marL="0">
+              <a:lnSpc>
+                <a:spcPct val="120000"/>
+              </a:lnSpc>
+              <a:buNone/>
+            </a:pPr>
+            <a:r>
+              <a:rPr lang="en-US" sz="1900" dirty="0">
                 <a:solidFill>
                   <a:srgbClr val="F5F0E0"/>
                 </a:solidFill>
@@ -11838,17 +11838,17 @@
               </a:rPr>
               <a:t>  • 以 sinfonia 引入 → ritornello 反覆</a:t>
             </a:r>
-            <a:endParaRPr lang="en-US" sz="2000" dirty="0"/>
-          </a:p>
-          <a:p>
-            <a:pPr indent="0" marL="0">
-              <a:lnSpc>
-                <a:spcPct val="130000"/>
-              </a:lnSpc>
-              <a:buNone/>
-            </a:pPr>
-            <a:r>
-              <a:rPr lang="en-US" sz="2000" dirty="0">
+            <a:endParaRPr lang="en-US" sz="1900" dirty="0"/>
+          </a:p>
+          <a:p>
+            <a:pPr indent="0" marL="0">
+              <a:lnSpc>
+                <a:spcPct val="120000"/>
+              </a:lnSpc>
+              <a:buNone/>
+            </a:pPr>
+            <a:r>
+              <a:rPr lang="en-US" sz="1900" dirty="0">
                 <a:solidFill>
                   <a:srgbClr val="F5F0E0"/>
                 </a:solidFill>
@@ -11858,26 +11858,26 @@
               </a:rPr>
               <a:t>  • 節奏活潑如 canzonetta 舞曲風格</a:t>
             </a:r>
-            <a:endParaRPr lang="en-US" sz="2000" dirty="0"/>
-          </a:p>
-          <a:p>
-            <a:pPr indent="0" marL="0">
-              <a:lnSpc>
-                <a:spcPct val="130000"/>
-              </a:lnSpc>
-              <a:buNone/>
-            </a:pPr>
-            <a:endParaRPr lang="en-US" sz="2000" dirty="0"/>
-          </a:p>
-          <a:p>
-            <a:pPr indent="0" marL="0">
-              <a:lnSpc>
-                <a:spcPct val="130000"/>
-              </a:lnSpc>
-              <a:buNone/>
-            </a:pPr>
-            <a:r>
-              <a:rPr lang="en-US" sz="2000" dirty="0">
+            <a:endParaRPr lang="en-US" sz="1900" dirty="0"/>
+          </a:p>
+          <a:p>
+            <a:pPr indent="0" marL="0">
+              <a:lnSpc>
+                <a:spcPct val="120000"/>
+              </a:lnSpc>
+              <a:buNone/>
+            </a:pPr>
+            <a:endParaRPr lang="en-US" sz="1900" dirty="0"/>
+          </a:p>
+          <a:p>
+            <a:pPr indent="0" marL="0">
+              <a:lnSpc>
+                <a:spcPct val="120000"/>
+              </a:lnSpc>
+              <a:buNone/>
+            </a:pPr>
+            <a:r>
+              <a:rPr lang="en-US" sz="1900" dirty="0">
                 <a:solidFill>
                   <a:srgbClr val="F5F0E0"/>
                 </a:solidFill>
@@ -11887,17 +11887,17 @@
               </a:rPr>
               <a:t>Dafne 報告死訊 — 敘事性宣敘調</a:t>
             </a:r>
-            <a:endParaRPr lang="en-US" sz="2000" dirty="0"/>
-          </a:p>
-          <a:p>
-            <a:pPr indent="0" marL="0">
-              <a:lnSpc>
-                <a:spcPct val="130000"/>
-              </a:lnSpc>
-              <a:buNone/>
-            </a:pPr>
-            <a:r>
-              <a:rPr lang="en-US" sz="2000" dirty="0">
+            <a:endParaRPr lang="en-US" sz="1900" dirty="0"/>
+          </a:p>
+          <a:p>
+            <a:pPr indent="0" marL="0">
+              <a:lnSpc>
+                <a:spcPct val="120000"/>
+              </a:lnSpc>
+              <a:buNone/>
+            </a:pPr>
+            <a:r>
+              <a:rPr lang="en-US" sz="1900" dirty="0">
                 <a:solidFill>
                   <a:srgbClr val="F5F0E0"/>
                 </a:solidFill>
@@ -11907,26 +11907,26 @@
               </a:rPr>
               <a:t>  • 無固定節奏、無旋律型態 → 純語言節奏</a:t>
             </a:r>
-            <a:endParaRPr lang="en-US" sz="2000" dirty="0"/>
-          </a:p>
-          <a:p>
-            <a:pPr indent="0" marL="0">
-              <a:lnSpc>
-                <a:spcPct val="130000"/>
-              </a:lnSpc>
-              <a:buNone/>
-            </a:pPr>
-            <a:endParaRPr lang="en-US" sz="2000" dirty="0"/>
-          </a:p>
-          <a:p>
-            <a:pPr indent="0" marL="0">
-              <a:lnSpc>
-                <a:spcPct val="130000"/>
-              </a:lnSpc>
-              <a:buNone/>
-            </a:pPr>
-            <a:r>
-              <a:rPr lang="en-US" sz="2000" dirty="0">
+            <a:endParaRPr lang="en-US" sz="1900" dirty="0"/>
+          </a:p>
+          <a:p>
+            <a:pPr indent="0" marL="0">
+              <a:lnSpc>
+                <a:spcPct val="120000"/>
+              </a:lnSpc>
+              <a:buNone/>
+            </a:pPr>
+            <a:endParaRPr lang="en-US" sz="1900" dirty="0"/>
+          </a:p>
+          <a:p>
+            <a:pPr indent="0" marL="0">
+              <a:lnSpc>
+                <a:spcPct val="120000"/>
+              </a:lnSpc>
+              <a:buNone/>
+            </a:pPr>
+            <a:r>
+              <a:rPr lang="en-US" sz="1900" dirty="0">
                 <a:solidFill>
                   <a:srgbClr val="F5F0E0"/>
                 </a:solidFill>
@@ -11936,17 +11936,17 @@
               </a:rPr>
               <a:t>Orfeo 哀歌 — 抒情性宣敘調</a:t>
             </a:r>
-            <a:endParaRPr lang="en-US" sz="2000" dirty="0"/>
-          </a:p>
-          <a:p>
-            <a:pPr indent="0" marL="0">
-              <a:lnSpc>
-                <a:spcPct val="130000"/>
-              </a:lnSpc>
-              <a:buNone/>
-            </a:pPr>
-            <a:r>
-              <a:rPr lang="en-US" sz="2000" dirty="0">
+            <a:endParaRPr lang="en-US" sz="1900" dirty="0"/>
+          </a:p>
+          <a:p>
+            <a:pPr indent="0" marL="0">
+              <a:lnSpc>
+                <a:spcPct val="120000"/>
+              </a:lnSpc>
+              <a:buNone/>
+            </a:pPr>
+            <a:r>
+              <a:rPr lang="en-US" sz="1900" dirty="0">
                 <a:solidFill>
                   <a:srgbClr val="F5F0E0"/>
                 </a:solidFill>
@@ -11956,7 +11956,7 @@
               </a:rPr>
               <a:t>  • 休止符表達驚愕、不協和表現悲痛</a:t>
             </a:r>
-            <a:endParaRPr lang="en-US" sz="2000" dirty="0"/>
+            <a:endParaRPr lang="en-US" sz="1900" dirty="0"/>
           </a:p>
         </p:txBody>
       </p:sp>
@@ -11970,8 +11970,8 @@
         </p:nvSpPr>
         <p:spPr>
           <a:xfrm>
-            <a:off x="457200" y="4617720"/>
-            <a:ext cx="8229600" cy="320040"/>
+            <a:off x="457200" y="4709160"/>
+            <a:ext cx="8229600" cy="274320"/>
           </a:xfrm>
           <a:prstGeom prst="rect">
             <a:avLst/>
@@ -11987,7 +11987,7 @@
               <a:buNone/>
             </a:pPr>
             <a:r>
-              <a:rPr lang="en-US" sz="1800" u="sng" dirty="0">
+              <a:rPr lang="en-US" sz="1600" u="sng" dirty="0">
                 <a:solidFill>
                   <a:srgbClr val="C8A030"/>
                 </a:solidFill>
@@ -12004,7 +12004,7 @@
               </a:rPr>
               <a:t>https://www.youtube.com/watch?v=bt8KaCIGBEk</a:t>
             </a:r>
-            <a:endParaRPr lang="en-US" sz="1800" dirty="0"/>
+            <a:endParaRPr lang="en-US" sz="1600" dirty="0"/>
           </a:p>
         </p:txBody>
       </p:sp>

</xml_diff>